<commit_message>
SEC project: presentation script, team briefing and speaker notes
Co-Authored-By: Claude Opus 5.5 <noreply@anthropic.com>
Claude-Session: https://claude.ai/code/session_015VN4M2s8EYDB3tD3YjqASb
</commit_message>
<xml_diff>
--- a/SEC_Project/SEC_Intelligent_USB_Electronics_Platform.pptx
+++ b/SEC_Project/SEC_Intelligent_USB_Electronics_Platform.pptx
@@ -508,7 +508,8 @@
           <a:p>
             <a:r>
               <a:rPr lang="en-US" dirty="0"/>
-              <a:t/>
+              <a:t>Speaker: Avi  ·  about 0:45
+Good morning. We are presenting our SEC project, Design and Development of an Intelligent USB-Based Electronics Platform, under the supervision of Prof. G.S. Chilana. I am Avi, with Harshit and Anshul; our team member Soham Pandit Nalawade could not be present today. In one line, our project is one small device that does the work of eight lab instruments, connects to a laptop with one USB cable, and has an AI engineer, called Proto, that runs tests and explains the results in plain language.</a:t>
             </a:r>
             <a:endParaRPr lang="en-US" dirty="0"/>
           </a:p>
@@ -596,7 +597,8 @@
           <a:p>
             <a:r>
               <a:rPr lang="en-US" dirty="0"/>
-              <a:t/>
+              <a:t>Speaker: Avi  ·  about 1:00
+Why did we build this? A normal electronics bench needs five to eight separate instruments: an oscilloscope, a function generator, a logic analyser, a multimeter and power supplies. They are costly and bulky, each has its own controls, and students often see a number without knowing what it means or what to fix. So our objectives are: put all eight instruments in one USB unit; build the core on an FPGA; give everything one software screen; add Proto, an AI engineer that plans tests and explains results; and keep it affordable for student labs.</a:t>
             </a:r>
             <a:endParaRPr lang="en-US" dirty="0"/>
           </a:p>
@@ -684,7 +686,8 @@
           <a:p>
             <a:r>
               <a:rPr lang="en-US" dirty="0"/>
-              <a:t/>
+              <a:t>Speaker: Harshit  ·  about 1:15
+This is how the hardware is organised. Read it from left to right. Each port on the left goes through a front end that protects and scales the signal, then through a converter. The two oscilloscope inputs use AD9226 chips, 12-bit converters that take 65 million readings per second. The waveform outputs use a 14-bit dual DAC. The 16 logic lines pass through a 74LVC245 buffer, the multimeter uses a precise 24-bit ADC, and the two power supplies are set by a small DAC and measured by an INA226 current monitor. Everything meets in the FPGA, the brain of the device. It handles triggering, captures data, generates waveforms and decodes buses, then sends everything over USB 2.0 to the computer, where our software and Proto run.</a:t>
             </a:r>
             <a:endParaRPr lang="en-US" dirty="0"/>
           </a:p>
@@ -772,7 +775,8 @@
           <a:p>
             <a:r>
               <a:rPr lang="en-US" dirty="0"/>
-              <a:t/>
+              <a:t>Speaker: Harshit  ·  about 1:00
+This is the front panel the user actually touches. CH1 and CH2 are the oscilloscope inputs. W1 and W2 are the signal generator outputs. The 16-pin header is for logic signals: the logic analyser, the pattern generator and the protocol decoder all use it. V1, V2 and COM are the two programmable power supplies, DMM is the multimeter input, and USB-C connects to the laptop. The table shows each instrument, its port, its key specification and the chip that does the job.</a:t>
             </a:r>
             <a:endParaRPr lang="en-US" dirty="0"/>
           </a:p>
@@ -860,7 +864,8 @@
           <a:p>
             <a:r>
               <a:rPr lang="en-US" dirty="0"/>
-              <a:t/>
+              <a:t>Speaker: Anshul  ·  about 1:00
+This is our software design. On the left you choose an instrument. In the middle is the oscilloscope screen with two waveforms, and below it the logic view decoding an I2C message into readable bytes. On the right are automatic measurements like frequency, voltage and rise time, and the Proto panel, where you can ask a question in plain English. On the right side of the slide is the software stack, from bottom to top: the FPGA logic, the USB link, the device interface, the workbench screen, and Proto at the top.</a:t>
             </a:r>
             <a:endParaRPr lang="en-US" dirty="0"/>
           </a:p>
@@ -948,7 +953,8 @@
           <a:p>
             <a:r>
               <a:rPr lang="en-US" dirty="0"/>
-              <a:t/>
+              <a:t>Speaker: Anshul  ·  about 1:15
+Proto is what makes the platform intelligent. It follows a fixed test flow: connect the board, power it up while watching the current, check every supply rail, drive the inputs, capture the outputs, decode the buses, give a verdict and suggest the fix. The first graph shows a frequency-response test of an RC filter. The generator sweeps the frequency, the scope measures the output, and Proto compares it with theory: the cutoff is one over two pi R C, about 1.59 kilohertz. The second graph checks each supply rail against a five percent tolerance. Here the sensor supply is 2.71 volts instead of 3.3, so Proto flags it and suggests what to check. These graphs show the test method with example data.</a:t>
             </a:r>
             <a:endParaRPr lang="en-US" dirty="0"/>
           </a:p>
@@ -1036,7 +1042,8 @@
           <a:p>
             <a:r>
               <a:rPr lang="en-US" dirty="0"/>
-              <a:t/>
+              <a:t>Speaker: Avi  ·  about 1:00
+Our method has seven phases: requirements and architecture, component selection, schematic and PCB design, FPGA logic, the workbench software, Proto integration, and finally testing and validation. The expected outcome is one USB unit that replaces eight bench instruments, runs tests as plans, and explains results in simple language at a cost student labs can afford. In future we want to add a probe fixture that reaches every point on a board automatically, more protocol decoders, remote lab access and automatic lab reports. Thank you. We are happy to take your questions.</a:t>
             </a:r>
             <a:endParaRPr lang="en-US" dirty="0"/>
           </a:p>

</xml_diff>